<commit_message>
docs(pitch): lámina 5 con A/B/C del motor (ensayo #285) y documentos alineados
- Lámina 5 de pitch-v3: totales, críticos a tiempo, puntaje y recomendación C
  del ensayo técnico local de #285 (PR #295, 1585ab7); sin desglose por
  componente, que en esa corrida no suma el total.
- Láminas 3 y 10: ya no dicen que A/B/C esté en integración.
- Guion (lámina 5, cortes de 3 y 7 min, viabilidad, cierre), video de respaldo,
  manifiesto, registro de ensayos y matriz de afirmaciones alineados.

Refs #200

Co-Authored-By: Claude Opus 5.5 <noreply@anthropic.com>
Claude-Session: https://claude.ai/code/session_01NsJaDshCcYpgTrfc71p237
</commit_message>
<xml_diff>
--- a/docs/specs/006-validacion-pitch-entrega/materiales/pitch-v3.pptx
+++ b/docs/specs/006-validacion-pitch-entrega/materiales/pitch-v3.pptx
@@ -4356,7 +4356,7 @@
                   </a:solidFill>
                   <a:latin typeface="Oswald"/>
                 </a:rPr>
-                <a:t>Integrar</a:t>
+                <a:t>Desplegar</a:t>
               </a:r>
             </a:p>
           </p:txBody>
@@ -4398,7 +4398,7 @@
                   </a:solidFill>
                   <a:latin typeface="Open Sans"/>
                 </a:rPr>
-                <a:t>Comparación propia / contratada y recomendación justificada</a:t>
+                <a:t>Comparación propia / contratada, en producción</a:t>
               </a:r>
             </a:p>
           </p:txBody>
@@ -8171,7 +8171,7 @@
                 </a:solidFill>
                 <a:latin typeface="Open Sans"/>
               </a:rPr>
-              <a:t>PROPUESTA · la comparación completa A/B/C sigue en integración</a:t>
+              <a:t>PROPUESTA · A/B/C ya ensayado en el motor; falta llevarlo a operación</a:t>
             </a:r>
           </a:p>
         </p:txBody>
@@ -9889,7 +9889,7 @@
                   </a:solidFill>
                   <a:latin typeface="Oswald"/>
                 </a:rPr>
-                <a:t>A / B / C: la columna A ya la calcula el motor</a:t>
+                <a:t>A / B / C: el motor compara y recomienda</a:t>
               </a:r>
             </a:p>
           </p:txBody>
@@ -10011,7 +10011,7 @@
                 </a:solidFill>
                 <a:latin typeface="Open Sans"/>
               </a:rPr>
-              <a:t>Fuente: #240, PR #254 (6adcf53), 240-desglose-demo.json · demo-base: Bodega Quito → Hospital Norte → regreso, 210 kg, 20 bultos, 1 ayudante · combustible sintético USD 3,785/gal · matriz P-01; P-02 en curso.</a:t>
+              <a:t>Fuente: ensayo técnico #285 (PR #295, 1585ab7), 02-suggest-pitch-abc.json · demo-quito-planificacion, corrida local 17-oct · 4 pedidos, 6 entregas críticas, 55,9 km · diésel USD 3,11/gal (Primicias, 12-oct) · matriz P-02.</a:t>
             </a:r>
           </a:p>
         </p:txBody>
@@ -10134,7 +10134,7 @@
                   </a:solidFill>
                   <a:latin typeface="Open Sans"/>
                 </a:rPr>
-                <a:t>A: costo estimado del motor · escenario demo-base · commit 6adcf53</a:t>
+                <a:t>Ensayo técnico del motor · escenario sintético de Quito</a:t>
               </a:r>
             </a:p>
           </p:txBody>
@@ -10149,9 +10149,9 @@
         <p:grpSpPr>
           <a:xfrm>
             <a:off x="685800" y="2011680"/>
-            <a:ext cx="8001000" cy="603504"/>
+            <a:ext cx="7772400" cy="603504"/>
             <a:chOff x="685800" y="2011680"/>
-            <a:chExt cx="8001000" cy="603504"/>
+            <a:chExt cx="7772400" cy="603504"/>
           </a:xfrm>
         </p:grpSpPr>
         <p:sp>
@@ -10163,7 +10163,7 @@
           <p:spPr>
             <a:xfrm>
               <a:off x="685800" y="2011680"/>
-              <a:ext cx="2468880" cy="603504"/>
+              <a:ext cx="2240280" cy="603504"/>
             </a:xfrm>
             <a:prstGeom prst="rect">
               <a:avLst/>
@@ -10192,7 +10192,7 @@
           <p:spPr>
             <a:xfrm>
               <a:off x="777240" y="2011680"/>
-              <a:ext cx="2286000" cy="603504"/>
+              <a:ext cx="2057400" cy="603504"/>
             </a:xfrm>
             <a:prstGeom prst="rect">
               <a:avLst/>
@@ -10220,7 +10220,7 @@
                   </a:solidFill>
                   <a:latin typeface="Oswald"/>
                 </a:rPr>
-                <a:t>Componente</a:t>
+                <a:t/>
               </a:r>
             </a:p>
           </p:txBody>
@@ -10233,8 +10233,8 @@
           </p:nvSpPr>
           <p:spPr>
             <a:xfrm>
-              <a:off x="3154680" y="2011680"/>
-              <a:ext cx="2240280" cy="603504"/>
+              <a:off x="2926080" y="2011680"/>
+              <a:ext cx="1783080" cy="603504"/>
             </a:xfrm>
             <a:prstGeom prst="rect">
               <a:avLst/>
@@ -10262,8 +10262,8 @@
           </p:nvSpPr>
           <p:spPr>
             <a:xfrm>
-              <a:off x="3246120" y="2011680"/>
-              <a:ext cx="2057400" cy="603504"/>
+              <a:off x="3017520" y="2011680"/>
+              <a:ext cx="1600200" cy="603504"/>
             </a:xfrm>
             <a:prstGeom prst="rect">
               <a:avLst/>
@@ -10304,14 +10304,14 @@
           </p:nvSpPr>
           <p:spPr>
             <a:xfrm>
-              <a:off x="5394960" y="2011680"/>
-              <a:ext cx="1645920" cy="603504"/>
+              <a:off x="4709160" y="2011680"/>
+              <a:ext cx="1783080" cy="603504"/>
             </a:xfrm>
             <a:prstGeom prst="rect">
               <a:avLst/>
             </a:prstGeom>
             <a:solidFill>
-              <a:srgbClr val="5B6585"/>
+              <a:srgbClr val="242D57"/>
             </a:solidFill>
             <a:ln>
               <a:noFill/>
@@ -10333,8 +10333,8 @@
           </p:nvSpPr>
           <p:spPr>
             <a:xfrm>
-              <a:off x="5486400" y="2011680"/>
-              <a:ext cx="1463040" cy="603504"/>
+              <a:off x="4800600" y="2011680"/>
+              <a:ext cx="1600200" cy="603504"/>
             </a:xfrm>
             <a:prstGeom prst="rect">
               <a:avLst/>
@@ -10375,14 +10375,14 @@
           </p:nvSpPr>
           <p:spPr>
             <a:xfrm>
-              <a:off x="7040880" y="2011680"/>
-              <a:ext cx="1645920" cy="603504"/>
+              <a:off x="6492240" y="2011680"/>
+              <a:ext cx="1965960" cy="603504"/>
             </a:xfrm>
             <a:prstGeom prst="rect">
               <a:avLst/>
             </a:prstGeom>
             <a:solidFill>
-              <a:srgbClr val="5B6585"/>
+              <a:srgbClr val="C4A857"/>
             </a:solidFill>
             <a:ln>
               <a:noFill/>
@@ -10404,8 +10404,8 @@
           </p:nvSpPr>
           <p:spPr>
             <a:xfrm>
-              <a:off x="7132320" y="2011680"/>
-              <a:ext cx="1463040" cy="603504"/>
+              <a:off x="6583680" y="2011680"/>
+              <a:ext cx="1783080" cy="603504"/>
             </a:xfrm>
             <a:prstGeom prst="rect">
               <a:avLst/>
@@ -10429,48 +10429,19 @@
               <a:r>
                 <a:rPr sz="1500" b="1" i="0">
                   <a:solidFill>
-                    <a:srgbClr val="FFFFFF"/>
+                    <a:srgbClr val="162451"/>
                   </a:solidFill>
                   <a:latin typeface="Oswald"/>
                 </a:rPr>
-                <a:t>C · Contratada</a:t>
+                <a:t>C · Operador contratado</a:t>
               </a:r>
-            </a:p>
-          </p:txBody>
-        </p:sp>
-        <p:sp>
-          <p:nvSpPr>
-            <p:cNvPr id="24" name="Rectangle 23"/>
-            <p:cNvSpPr/>
-            <p:nvPr/>
-          </p:nvSpPr>
-          <p:spPr>
-            <a:xfrm>
-              <a:off x="3154680" y="2578608"/>
-              <a:ext cx="2240280" cy="36576"/>
-            </a:xfrm>
-            <a:prstGeom prst="rect">
-              <a:avLst/>
-            </a:prstGeom>
-            <a:solidFill>
-              <a:srgbClr val="C4A857"/>
-            </a:solidFill>
-            <a:ln>
-              <a:noFill/>
-            </a:ln>
-          </p:spPr>
-          <p:txBody>
-            <a:bodyPr rtlCol="0" anchor="ctr"/>
-            <a:lstStyle/>
-            <a:p>
-              <a:pPr algn="ctr"/>
             </a:p>
           </p:txBody>
         </p:sp>
       </p:grpSp>
       <p:pic>
         <p:nvPicPr>
-          <p:cNvPr id="25" name="Picture 24" descr="chillo-medio-cuerpo.png"/>
+          <p:cNvPr id="24" name="Picture 23" descr="chillo-medio-cuerpo.png"/>
           <p:cNvPicPr>
             <a:picLocks noChangeAspect="1"/>
           </p:cNvPicPr>
@@ -10494,28 +10465,28 @@
       </p:pic>
       <p:grpSp>
         <p:nvGrpSpPr>
-          <p:cNvPr id="26" name="Group 25"/>
+          <p:cNvPr id="25" name="Group 24"/>
           <p:cNvGrpSpPr/>
           <p:nvPr/>
         </p:nvGrpSpPr>
         <p:grpSpPr>
           <a:xfrm>
             <a:off x="685800" y="2615184"/>
-            <a:ext cx="8001000" cy="429768"/>
+            <a:ext cx="7772400" cy="457200"/>
             <a:chOff x="685800" y="2615184"/>
-            <a:chExt cx="8001000" cy="429768"/>
+            <a:chExt cx="7772400" cy="457200"/>
           </a:xfrm>
         </p:grpSpPr>
         <p:sp>
           <p:nvSpPr>
-            <p:cNvPr id="27" name="Rectangle 26"/>
+            <p:cNvPr id="26" name="Rectangle 25"/>
             <p:cNvSpPr/>
             <p:nvPr/>
           </p:nvSpPr>
           <p:spPr>
             <a:xfrm>
               <a:off x="685800" y="2615184"/>
-              <a:ext cx="2468880" cy="429768"/>
+              <a:ext cx="2240280" cy="457200"/>
             </a:xfrm>
             <a:prstGeom prst="rect">
               <a:avLst/>
@@ -10537,14 +10508,14 @@
         </p:sp>
         <p:sp>
           <p:nvSpPr>
-            <p:cNvPr id="28" name="TextBox 27"/>
+            <p:cNvPr id="27" name="TextBox 26"/>
             <p:cNvSpPr txBox="1"/>
             <p:nvPr/>
           </p:nvSpPr>
           <p:spPr>
             <a:xfrm>
               <a:off x="868680" y="2615184"/>
-              <a:ext cx="2240280" cy="429768"/>
+              <a:ext cx="2011680" cy="457200"/>
             </a:xfrm>
             <a:prstGeom prst="rect">
               <a:avLst/>
@@ -10569,21 +10540,21 @@
                   </a:solidFill>
                   <a:latin typeface="Open Sans"/>
                 </a:rPr>
-                <a:t>Combustible</a:t>
+                <a:t>Flota</a:t>
               </a:r>
             </a:p>
           </p:txBody>
         </p:sp>
         <p:sp>
           <p:nvSpPr>
-            <p:cNvPr id="29" name="Rectangle 28"/>
+            <p:cNvPr id="28" name="Rectangle 27"/>
             <p:cNvSpPr/>
             <p:nvPr/>
           </p:nvSpPr>
           <p:spPr>
             <a:xfrm>
-              <a:off x="3154680" y="2615184"/>
-              <a:ext cx="2240280" cy="429768"/>
+              <a:off x="2926080" y="2615184"/>
+              <a:ext cx="1783080" cy="457200"/>
             </a:xfrm>
             <a:prstGeom prst="rect">
               <a:avLst/>
@@ -10605,14 +10576,14 @@
         </p:sp>
         <p:sp>
           <p:nvSpPr>
-            <p:cNvPr id="30" name="TextBox 29"/>
+            <p:cNvPr id="29" name="TextBox 28"/>
             <p:cNvSpPr txBox="1"/>
             <p:nvPr/>
           </p:nvSpPr>
           <p:spPr>
             <a:xfrm>
-              <a:off x="3246120" y="2615184"/>
-              <a:ext cx="2057400" cy="429768"/>
+              <a:off x="3017520" y="2615184"/>
+              <a:ext cx="1600200" cy="457200"/>
             </a:xfrm>
             <a:prstGeom prst="rect">
               <a:avLst/>
@@ -10631,27 +10602,27 @@
                 </a:spcAft>
               </a:pPr>
               <a:r>
-                <a:rPr sz="1900" b="1" i="0">
+                <a:rPr sz="1800" b="1" i="0">
                   <a:solidFill>
                     <a:srgbClr val="242D57"/>
                   </a:solidFill>
                   <a:latin typeface="Oswald"/>
                 </a:rPr>
-                <a:t>USD 2,26</a:t>
+                <a:t>Propia</a:t>
               </a:r>
             </a:p>
           </p:txBody>
         </p:sp>
         <p:sp>
           <p:nvSpPr>
-            <p:cNvPr id="31" name="Rectangle 30"/>
+            <p:cNvPr id="30" name="Rectangle 29"/>
             <p:cNvSpPr/>
             <p:nvPr/>
           </p:nvSpPr>
           <p:spPr>
             <a:xfrm>
-              <a:off x="5394960" y="2615184"/>
-              <a:ext cx="1645920" cy="429768"/>
+              <a:off x="4709160" y="2615184"/>
+              <a:ext cx="1783080" cy="457200"/>
             </a:xfrm>
             <a:prstGeom prst="rect">
               <a:avLst/>
@@ -10673,14 +10644,14 @@
         </p:sp>
         <p:sp>
           <p:nvSpPr>
-            <p:cNvPr id="32" name="TextBox 31"/>
+            <p:cNvPr id="31" name="TextBox 30"/>
             <p:cNvSpPr txBox="1"/>
             <p:nvPr/>
           </p:nvSpPr>
           <p:spPr>
             <a:xfrm>
-              <a:off x="5486400" y="2615184"/>
-              <a:ext cx="1463040" cy="429768"/>
+              <a:off x="4800600" y="2615184"/>
+              <a:ext cx="1600200" cy="457200"/>
             </a:xfrm>
             <a:prstGeom prst="rect">
               <a:avLst/>
@@ -10699,33 +10670,33 @@
                 </a:spcAft>
               </a:pPr>
               <a:r>
-                <a:rPr sz="1300" b="0" i="1">
+                <a:rPr sz="1800" b="1" i="0">
                   <a:solidFill>
-                    <a:srgbClr val="5B6585"/>
+                    <a:srgbClr val="242D57"/>
                   </a:solidFill>
-                  <a:latin typeface="Open Sans"/>
+                  <a:latin typeface="Oswald"/>
                 </a:rPr>
-                <a:t>en integración</a:t>
+                <a:t>Propia</a:t>
               </a:r>
             </a:p>
           </p:txBody>
         </p:sp>
         <p:sp>
           <p:nvSpPr>
-            <p:cNvPr id="33" name="Rectangle 32"/>
+            <p:cNvPr id="32" name="Rectangle 31"/>
             <p:cNvSpPr/>
             <p:nvPr/>
           </p:nvSpPr>
           <p:spPr>
             <a:xfrm>
-              <a:off x="7040880" y="2615184"/>
-              <a:ext cx="1645920" cy="429768"/>
+              <a:off x="6492240" y="2615184"/>
+              <a:ext cx="1965960" cy="457200"/>
             </a:xfrm>
             <a:prstGeom prst="rect">
               <a:avLst/>
             </a:prstGeom>
             <a:solidFill>
-              <a:srgbClr val="FFFFFF"/>
+              <a:srgbClr val="F7F1DF"/>
             </a:solidFill>
             <a:ln>
               <a:noFill/>
@@ -10741,14 +10712,14 @@
         </p:sp>
         <p:sp>
           <p:nvSpPr>
-            <p:cNvPr id="34" name="TextBox 33"/>
+            <p:cNvPr id="33" name="TextBox 32"/>
             <p:cNvSpPr txBox="1"/>
             <p:nvPr/>
           </p:nvSpPr>
           <p:spPr>
             <a:xfrm>
-              <a:off x="7132320" y="2615184"/>
-              <a:ext cx="1463040" cy="429768"/>
+              <a:off x="6583680" y="2615184"/>
+              <a:ext cx="1783080" cy="457200"/>
             </a:xfrm>
             <a:prstGeom prst="rect">
               <a:avLst/>
@@ -10767,27 +10738,27 @@
                 </a:spcAft>
               </a:pPr>
               <a:r>
-                <a:rPr sz="1300" b="0" i="1">
+                <a:rPr sz="1800" b="1" i="0">
                   <a:solidFill>
-                    <a:srgbClr val="5B6585"/>
+                    <a:srgbClr val="7D6520"/>
                   </a:solidFill>
-                  <a:latin typeface="Open Sans"/>
+                  <a:latin typeface="Oswald"/>
                 </a:rPr>
-                <a:t>en integración</a:t>
+                <a:t>Contratada</a:t>
               </a:r>
             </a:p>
           </p:txBody>
         </p:sp>
         <p:sp>
           <p:nvSpPr>
-            <p:cNvPr id="35" name="Rectangle 34"/>
+            <p:cNvPr id="34" name="Rectangle 33"/>
             <p:cNvSpPr/>
             <p:nvPr/>
           </p:nvSpPr>
           <p:spPr>
             <a:xfrm>
-              <a:off x="685800" y="3033979"/>
-              <a:ext cx="8001000" cy="10972"/>
+              <a:off x="685800" y="3061411"/>
+              <a:ext cx="7772400" cy="10972"/>
             </a:xfrm>
             <a:prstGeom prst="rect">
               <a:avLst/>
@@ -10810,28 +10781,28 @@
       </p:grpSp>
       <p:grpSp>
         <p:nvGrpSpPr>
-          <p:cNvPr id="36" name="Group 35"/>
+          <p:cNvPr id="35" name="Group 34"/>
           <p:cNvGrpSpPr/>
           <p:nvPr/>
         </p:nvGrpSpPr>
         <p:grpSpPr>
           <a:xfrm>
-            <a:off x="685800" y="3044952"/>
-            <a:ext cx="8001000" cy="429768"/>
-            <a:chOff x="685800" y="3044952"/>
-            <a:chExt cx="8001000" cy="429768"/>
+            <a:off x="685800" y="3072384"/>
+            <a:ext cx="7772400" cy="457200"/>
+            <a:chOff x="685800" y="3072384"/>
+            <a:chExt cx="7772400" cy="457200"/>
           </a:xfrm>
         </p:grpSpPr>
         <p:sp>
           <p:nvSpPr>
-            <p:cNvPr id="37" name="Rectangle 36"/>
+            <p:cNvPr id="36" name="Rectangle 35"/>
             <p:cNvSpPr/>
             <p:nvPr/>
           </p:nvSpPr>
           <p:spPr>
             <a:xfrm>
-              <a:off x="685800" y="3044952"/>
-              <a:ext cx="2468880" cy="429768"/>
+              <a:off x="685800" y="3072384"/>
+              <a:ext cx="2240280" cy="457200"/>
             </a:xfrm>
             <a:prstGeom prst="rect">
               <a:avLst/>
@@ -10853,14 +10824,14 @@
         </p:sp>
         <p:sp>
           <p:nvSpPr>
-            <p:cNvPr id="38" name="TextBox 37"/>
+            <p:cNvPr id="37" name="TextBox 36"/>
             <p:cNvSpPr txBox="1"/>
             <p:nvPr/>
           </p:nvSpPr>
           <p:spPr>
             <a:xfrm>
-              <a:off x="868680" y="3044952"/>
-              <a:ext cx="2240280" cy="429768"/>
+              <a:off x="868680" y="3072384"/>
+              <a:ext cx="2011680" cy="457200"/>
             </a:xfrm>
             <a:prstGeom prst="rect">
               <a:avLst/>
@@ -10885,21 +10856,21 @@
                   </a:solidFill>
                   <a:latin typeface="Open Sans"/>
                 </a:rPr>
-                <a:t>Desgaste</a:t>
+                <a:t>Críticos a tiempo</a:t>
               </a:r>
             </a:p>
           </p:txBody>
         </p:sp>
         <p:sp>
           <p:nvSpPr>
-            <p:cNvPr id="39" name="Rectangle 38"/>
+            <p:cNvPr id="38" name="Rectangle 37"/>
             <p:cNvSpPr/>
             <p:nvPr/>
           </p:nvSpPr>
           <p:spPr>
             <a:xfrm>
-              <a:off x="3154680" y="3044952"/>
-              <a:ext cx="2240280" cy="429768"/>
+              <a:off x="2926080" y="3072384"/>
+              <a:ext cx="1783080" cy="457200"/>
             </a:xfrm>
             <a:prstGeom prst="rect">
               <a:avLst/>
@@ -10921,14 +10892,14 @@
         </p:sp>
         <p:sp>
           <p:nvSpPr>
-            <p:cNvPr id="40" name="TextBox 39"/>
+            <p:cNvPr id="39" name="TextBox 38"/>
             <p:cNvSpPr txBox="1"/>
             <p:nvPr/>
           </p:nvSpPr>
           <p:spPr>
             <a:xfrm>
-              <a:off x="3246120" y="3044952"/>
-              <a:ext cx="2057400" cy="429768"/>
+              <a:off x="3017520" y="3072384"/>
+              <a:ext cx="1600200" cy="457200"/>
             </a:xfrm>
             <a:prstGeom prst="rect">
               <a:avLst/>
@@ -10947,27 +10918,27 @@
                 </a:spcAft>
               </a:pPr>
               <a:r>
-                <a:rPr sz="1900" b="1" i="0">
+                <a:rPr sz="1800" b="1" i="0">
                   <a:solidFill>
                     <a:srgbClr val="242D57"/>
                   </a:solidFill>
                   <a:latin typeface="Oswald"/>
                 </a:rPr>
-                <a:t>USD 2,15</a:t>
+                <a:t>5 de 6</a:t>
               </a:r>
             </a:p>
           </p:txBody>
         </p:sp>
         <p:sp>
           <p:nvSpPr>
-            <p:cNvPr id="41" name="Rectangle 40"/>
+            <p:cNvPr id="40" name="Rectangle 39"/>
             <p:cNvSpPr/>
             <p:nvPr/>
           </p:nvSpPr>
           <p:spPr>
             <a:xfrm>
-              <a:off x="5394960" y="3044952"/>
-              <a:ext cx="1645920" cy="429768"/>
+              <a:off x="4709160" y="3072384"/>
+              <a:ext cx="1783080" cy="457200"/>
             </a:xfrm>
             <a:prstGeom prst="rect">
               <a:avLst/>
@@ -10989,14 +10960,14 @@
         </p:sp>
         <p:sp>
           <p:nvSpPr>
-            <p:cNvPr id="42" name="TextBox 41"/>
+            <p:cNvPr id="41" name="TextBox 40"/>
             <p:cNvSpPr txBox="1"/>
             <p:nvPr/>
           </p:nvSpPr>
           <p:spPr>
             <a:xfrm>
-              <a:off x="5486400" y="3044952"/>
-              <a:ext cx="1463040" cy="429768"/>
+              <a:off x="4800600" y="3072384"/>
+              <a:ext cx="1600200" cy="457200"/>
             </a:xfrm>
             <a:prstGeom prst="rect">
               <a:avLst/>
@@ -11015,33 +10986,33 @@
                 </a:spcAft>
               </a:pPr>
               <a:r>
-                <a:rPr sz="1300" b="0" i="1">
+                <a:rPr sz="1800" b="1" i="0">
                   <a:solidFill>
-                    <a:srgbClr val="5B6585"/>
+                    <a:srgbClr val="242D57"/>
                   </a:solidFill>
-                  <a:latin typeface="Open Sans"/>
+                  <a:latin typeface="Oswald"/>
                 </a:rPr>
-                <a:t>en integración</a:t>
+                <a:t>6 de 6</a:t>
               </a:r>
             </a:p>
           </p:txBody>
         </p:sp>
         <p:sp>
           <p:nvSpPr>
-            <p:cNvPr id="43" name="Rectangle 42"/>
+            <p:cNvPr id="42" name="Rectangle 41"/>
             <p:cNvSpPr/>
             <p:nvPr/>
           </p:nvSpPr>
           <p:spPr>
             <a:xfrm>
-              <a:off x="7040880" y="3044952"/>
-              <a:ext cx="1645920" cy="429768"/>
+              <a:off x="6492240" y="3072384"/>
+              <a:ext cx="1965960" cy="457200"/>
             </a:xfrm>
             <a:prstGeom prst="rect">
               <a:avLst/>
             </a:prstGeom>
             <a:solidFill>
-              <a:srgbClr val="EDF0F7"/>
+              <a:srgbClr val="F1E8CB"/>
             </a:solidFill>
             <a:ln>
               <a:noFill/>
@@ -11057,14 +11028,14 @@
         </p:sp>
         <p:sp>
           <p:nvSpPr>
-            <p:cNvPr id="44" name="TextBox 43"/>
+            <p:cNvPr id="43" name="TextBox 42"/>
             <p:cNvSpPr txBox="1"/>
             <p:nvPr/>
           </p:nvSpPr>
           <p:spPr>
             <a:xfrm>
-              <a:off x="7132320" y="3044952"/>
-              <a:ext cx="1463040" cy="429768"/>
+              <a:off x="6583680" y="3072384"/>
+              <a:ext cx="1783080" cy="457200"/>
             </a:xfrm>
             <a:prstGeom prst="rect">
               <a:avLst/>
@@ -11083,27 +11054,27 @@
                 </a:spcAft>
               </a:pPr>
               <a:r>
-                <a:rPr sz="1300" b="0" i="1">
+                <a:rPr sz="1800" b="1" i="0">
                   <a:solidFill>
-                    <a:srgbClr val="5B6585"/>
+                    <a:srgbClr val="7D6520"/>
                   </a:solidFill>
-                  <a:latin typeface="Open Sans"/>
+                  <a:latin typeface="Oswald"/>
                 </a:rPr>
-                <a:t>en integración</a:t>
+                <a:t>6 de 6</a:t>
               </a:r>
             </a:p>
           </p:txBody>
         </p:sp>
         <p:sp>
           <p:nvSpPr>
-            <p:cNvPr id="45" name="Rectangle 44"/>
+            <p:cNvPr id="44" name="Rectangle 43"/>
             <p:cNvSpPr/>
             <p:nvPr/>
           </p:nvSpPr>
           <p:spPr>
             <a:xfrm>
-              <a:off x="685800" y="3463747"/>
-              <a:ext cx="8001000" cy="10972"/>
+              <a:off x="685800" y="3518611"/>
+              <a:ext cx="7772400" cy="10972"/>
             </a:xfrm>
             <a:prstGeom prst="rect">
               <a:avLst/>
@@ -11126,28 +11097,28 @@
       </p:grpSp>
       <p:grpSp>
         <p:nvGrpSpPr>
-          <p:cNvPr id="46" name="Group 45"/>
+          <p:cNvPr id="45" name="Group 44"/>
           <p:cNvGrpSpPr/>
           <p:nvPr/>
         </p:nvGrpSpPr>
         <p:grpSpPr>
           <a:xfrm>
-            <a:off x="685800" y="3474720"/>
-            <a:ext cx="8001000" cy="429768"/>
-            <a:chOff x="685800" y="3474720"/>
-            <a:chExt cx="8001000" cy="429768"/>
+            <a:off x="685800" y="3529584"/>
+            <a:ext cx="7772400" cy="457200"/>
+            <a:chOff x="685800" y="3529584"/>
+            <a:chExt cx="7772400" cy="457200"/>
           </a:xfrm>
         </p:grpSpPr>
         <p:sp>
           <p:nvSpPr>
-            <p:cNvPr id="47" name="Rectangle 46"/>
+            <p:cNvPr id="46" name="Rectangle 45"/>
             <p:cNvSpPr/>
             <p:nvPr/>
           </p:nvSpPr>
           <p:spPr>
             <a:xfrm>
-              <a:off x="685800" y="3474720"/>
-              <a:ext cx="2468880" cy="429768"/>
+              <a:off x="685800" y="3529584"/>
+              <a:ext cx="2240280" cy="457200"/>
             </a:xfrm>
             <a:prstGeom prst="rect">
               <a:avLst/>
@@ -11169,14 +11140,14 @@
         </p:sp>
         <p:sp>
           <p:nvSpPr>
-            <p:cNvPr id="48" name="TextBox 47"/>
+            <p:cNvPr id="47" name="TextBox 46"/>
             <p:cNvSpPr txBox="1"/>
             <p:nvPr/>
           </p:nvSpPr>
           <p:spPr>
             <a:xfrm>
-              <a:off x="868680" y="3474720"/>
-              <a:ext cx="2240280" cy="429768"/>
+              <a:off x="868680" y="3529584"/>
+              <a:ext cx="2011680" cy="457200"/>
             </a:xfrm>
             <a:prstGeom prst="rect">
               <a:avLst/>
@@ -11201,21 +11172,21 @@
                   </a:solidFill>
                   <a:latin typeface="Open Sans"/>
                 </a:rPr>
-                <a:t>Conductor y ayudantes</a:t>
+                <a:t>Puntaje del motor</a:t>
               </a:r>
             </a:p>
           </p:txBody>
         </p:sp>
         <p:sp>
           <p:nvSpPr>
-            <p:cNvPr id="49" name="Rectangle 48"/>
+            <p:cNvPr id="48" name="Rectangle 47"/>
             <p:cNvSpPr/>
             <p:nvPr/>
           </p:nvSpPr>
           <p:spPr>
             <a:xfrm>
-              <a:off x="3154680" y="3474720"/>
-              <a:ext cx="2240280" cy="429768"/>
+              <a:off x="2926080" y="3529584"/>
+              <a:ext cx="1783080" cy="457200"/>
             </a:xfrm>
             <a:prstGeom prst="rect">
               <a:avLst/>
@@ -11237,14 +11208,14 @@
         </p:sp>
         <p:sp>
           <p:nvSpPr>
-            <p:cNvPr id="50" name="TextBox 49"/>
+            <p:cNvPr id="49" name="TextBox 48"/>
             <p:cNvSpPr txBox="1"/>
             <p:nvPr/>
           </p:nvSpPr>
           <p:spPr>
             <a:xfrm>
-              <a:off x="3246120" y="3474720"/>
-              <a:ext cx="2057400" cy="429768"/>
+              <a:off x="3017520" y="3529584"/>
+              <a:ext cx="1600200" cy="457200"/>
             </a:xfrm>
             <a:prstGeom prst="rect">
               <a:avLst/>
@@ -11263,27 +11234,27 @@
                 </a:spcAft>
               </a:pPr>
               <a:r>
-                <a:rPr sz="1900" b="1" i="0">
+                <a:rPr sz="1800" b="1" i="0">
                   <a:solidFill>
                     <a:srgbClr val="242D57"/>
                   </a:solidFill>
                   <a:latin typeface="Oswald"/>
                 </a:rPr>
-                <a:t>USD 7,22 + 4,81</a:t>
+                <a:t>81,7</a:t>
               </a:r>
             </a:p>
           </p:txBody>
         </p:sp>
         <p:sp>
           <p:nvSpPr>
-            <p:cNvPr id="51" name="Rectangle 50"/>
+            <p:cNvPr id="50" name="Rectangle 49"/>
             <p:cNvSpPr/>
             <p:nvPr/>
           </p:nvSpPr>
           <p:spPr>
             <a:xfrm>
-              <a:off x="5394960" y="3474720"/>
-              <a:ext cx="1645920" cy="429768"/>
+              <a:off x="4709160" y="3529584"/>
+              <a:ext cx="1783080" cy="457200"/>
             </a:xfrm>
             <a:prstGeom prst="rect">
               <a:avLst/>
@@ -11305,14 +11276,14 @@
         </p:sp>
         <p:sp>
           <p:nvSpPr>
-            <p:cNvPr id="52" name="TextBox 51"/>
+            <p:cNvPr id="51" name="TextBox 50"/>
             <p:cNvSpPr txBox="1"/>
             <p:nvPr/>
           </p:nvSpPr>
           <p:spPr>
             <a:xfrm>
-              <a:off x="5486400" y="3474720"/>
-              <a:ext cx="1463040" cy="429768"/>
+              <a:off x="4800600" y="3529584"/>
+              <a:ext cx="1600200" cy="457200"/>
             </a:xfrm>
             <a:prstGeom prst="rect">
               <a:avLst/>
@@ -11331,33 +11302,33 @@
                 </a:spcAft>
               </a:pPr>
               <a:r>
-                <a:rPr sz="1300" b="0" i="1">
+                <a:rPr sz="1800" b="1" i="0">
                   <a:solidFill>
-                    <a:srgbClr val="5B6585"/>
+                    <a:srgbClr val="242D57"/>
                   </a:solidFill>
-                  <a:latin typeface="Open Sans"/>
+                  <a:latin typeface="Oswald"/>
                 </a:rPr>
-                <a:t>en integración</a:t>
+                <a:t>89,1</a:t>
               </a:r>
             </a:p>
           </p:txBody>
         </p:sp>
         <p:sp>
           <p:nvSpPr>
-            <p:cNvPr id="53" name="Rectangle 52"/>
+            <p:cNvPr id="52" name="Rectangle 51"/>
             <p:cNvSpPr/>
             <p:nvPr/>
           </p:nvSpPr>
           <p:spPr>
             <a:xfrm>
-              <a:off x="7040880" y="3474720"/>
-              <a:ext cx="1645920" cy="429768"/>
+              <a:off x="6492240" y="3529584"/>
+              <a:ext cx="1965960" cy="457200"/>
             </a:xfrm>
             <a:prstGeom prst="rect">
               <a:avLst/>
             </a:prstGeom>
             <a:solidFill>
-              <a:srgbClr val="FFFFFF"/>
+              <a:srgbClr val="F7F1DF"/>
             </a:solidFill>
             <a:ln>
               <a:noFill/>
@@ -11373,14 +11344,14 @@
         </p:sp>
         <p:sp>
           <p:nvSpPr>
-            <p:cNvPr id="54" name="TextBox 53"/>
+            <p:cNvPr id="53" name="TextBox 52"/>
             <p:cNvSpPr txBox="1"/>
             <p:nvPr/>
           </p:nvSpPr>
           <p:spPr>
             <a:xfrm>
-              <a:off x="7132320" y="3474720"/>
-              <a:ext cx="1463040" cy="429768"/>
+              <a:off x="6583680" y="3529584"/>
+              <a:ext cx="1783080" cy="457200"/>
             </a:xfrm>
             <a:prstGeom prst="rect">
               <a:avLst/>
@@ -11399,27 +11370,27 @@
                 </a:spcAft>
               </a:pPr>
               <a:r>
-                <a:rPr sz="1300" b="0" i="1">
+                <a:rPr sz="1800" b="1" i="0">
                   <a:solidFill>
-                    <a:srgbClr val="5B6585"/>
+                    <a:srgbClr val="7D6520"/>
                   </a:solidFill>
-                  <a:latin typeface="Open Sans"/>
+                  <a:latin typeface="Oswald"/>
                 </a:rPr>
-                <a:t>en integración</a:t>
+                <a:t>90,8</a:t>
               </a:r>
             </a:p>
           </p:txBody>
         </p:sp>
         <p:sp>
           <p:nvSpPr>
-            <p:cNvPr id="55" name="Rectangle 54"/>
+            <p:cNvPr id="54" name="Rectangle 53"/>
             <p:cNvSpPr/>
             <p:nvPr/>
           </p:nvSpPr>
           <p:spPr>
             <a:xfrm>
-              <a:off x="685800" y="3893515"/>
-              <a:ext cx="8001000" cy="10972"/>
+              <a:off x="685800" y="3975811"/>
+              <a:ext cx="7772400" cy="10972"/>
             </a:xfrm>
             <a:prstGeom prst="rect">
               <a:avLst/>
@@ -11442,34 +11413,34 @@
       </p:grpSp>
       <p:grpSp>
         <p:nvGrpSpPr>
-          <p:cNvPr id="56" name="Group 55"/>
+          <p:cNvPr id="55" name="Group 54"/>
           <p:cNvGrpSpPr/>
           <p:nvPr/>
         </p:nvGrpSpPr>
         <p:grpSpPr>
           <a:xfrm>
-            <a:off x="685800" y="3904487"/>
-            <a:ext cx="8001000" cy="429768"/>
-            <a:chOff x="685800" y="3904487"/>
-            <a:chExt cx="8001000" cy="429768"/>
+            <a:off x="685800" y="3986784"/>
+            <a:ext cx="7772400" cy="585216"/>
+            <a:chOff x="685800" y="3986784"/>
+            <a:chExt cx="7772400" cy="585216"/>
           </a:xfrm>
         </p:grpSpPr>
         <p:sp>
           <p:nvSpPr>
-            <p:cNvPr id="57" name="Rectangle 56"/>
+            <p:cNvPr id="56" name="Rectangle 55"/>
             <p:cNvSpPr/>
             <p:nvPr/>
           </p:nvSpPr>
           <p:spPr>
             <a:xfrm>
-              <a:off x="685800" y="3904487"/>
-              <a:ext cx="2468880" cy="429768"/>
+              <a:off x="685800" y="3986784"/>
+              <a:ext cx="2240280" cy="585216"/>
             </a:xfrm>
             <a:prstGeom prst="rect">
               <a:avLst/>
             </a:prstGeom>
             <a:solidFill>
-              <a:srgbClr val="EDF0F7"/>
+              <a:srgbClr val="F7F1DF"/>
             </a:solidFill>
             <a:ln>
               <a:noFill/>
@@ -11485,14 +11456,14 @@
         </p:sp>
         <p:sp>
           <p:nvSpPr>
-            <p:cNvPr id="58" name="TextBox 57"/>
+            <p:cNvPr id="57" name="TextBox 56"/>
             <p:cNvSpPr txBox="1"/>
             <p:nvPr/>
           </p:nvSpPr>
           <p:spPr>
             <a:xfrm>
-              <a:off x="868680" y="3904487"/>
-              <a:ext cx="2240280" cy="429768"/>
+              <a:off x="868680" y="3986784"/>
+              <a:ext cx="2011680" cy="585216"/>
             </a:xfrm>
             <a:prstGeom prst="rect">
               <a:avLst/>
@@ -11517,21 +11488,327 @@
                   </a:solidFill>
                   <a:latin typeface="Open Sans"/>
                 </a:rPr>
-                <a:t>Merma esperada</a:t>
+                <a:t>Costo total estimado</a:t>
               </a:r>
             </a:p>
           </p:txBody>
         </p:sp>
         <p:sp>
           <p:nvSpPr>
-            <p:cNvPr id="59" name="Rectangle 58"/>
+            <p:cNvPr id="58" name="Rectangle 57"/>
             <p:cNvSpPr/>
             <p:nvPr/>
           </p:nvSpPr>
           <p:spPr>
             <a:xfrm>
-              <a:off x="3154680" y="3904487"/>
-              <a:ext cx="2240280" cy="429768"/>
+              <a:off x="2926080" y="3986784"/>
+              <a:ext cx="1783080" cy="585216"/>
+            </a:xfrm>
+            <a:prstGeom prst="rect">
+              <a:avLst/>
+            </a:prstGeom>
+            <a:solidFill>
+              <a:srgbClr val="F7F1DF"/>
+            </a:solidFill>
+            <a:ln>
+              <a:noFill/>
+            </a:ln>
+          </p:spPr>
+          <p:txBody>
+            <a:bodyPr rtlCol="0" anchor="ctr"/>
+            <a:lstStyle/>
+            <a:p>
+              <a:pPr algn="ctr"/>
+            </a:p>
+          </p:txBody>
+        </p:sp>
+        <p:sp>
+          <p:nvSpPr>
+            <p:cNvPr id="59" name="TextBox 58"/>
+            <p:cNvSpPr txBox="1"/>
+            <p:nvPr/>
+          </p:nvSpPr>
+          <p:spPr>
+            <a:xfrm>
+              <a:off x="3017520" y="3986784"/>
+              <a:ext cx="1600200" cy="585216"/>
+            </a:xfrm>
+            <a:prstGeom prst="rect">
+              <a:avLst/>
+            </a:prstGeom>
+            <a:noFill/>
+          </p:spPr>
+          <p:txBody>
+            <a:bodyPr wrap="square" anchor="ctr" lIns="0" rIns="0" tIns="0" bIns="0">
+              <a:spAutoFit/>
+            </a:bodyPr>
+            <a:lstStyle/>
+            <a:p>
+              <a:pPr algn="ctr">
+                <a:spcAft>
+                  <a:spcPts val="0"/>
+                </a:spcAft>
+              </a:pPr>
+              <a:r>
+                <a:rPr sz="2400" b="1" i="0">
+                  <a:solidFill>
+                    <a:srgbClr val="242D57"/>
+                  </a:solidFill>
+                  <a:latin typeface="Oswald"/>
+                </a:rPr>
+                <a:t>USD 57,89</a:t>
+              </a:r>
+            </a:p>
+          </p:txBody>
+        </p:sp>
+        <p:sp>
+          <p:nvSpPr>
+            <p:cNvPr id="60" name="Rectangle 59"/>
+            <p:cNvSpPr/>
+            <p:nvPr/>
+          </p:nvSpPr>
+          <p:spPr>
+            <a:xfrm>
+              <a:off x="4709160" y="3986784"/>
+              <a:ext cx="1783080" cy="585216"/>
+            </a:xfrm>
+            <a:prstGeom prst="rect">
+              <a:avLst/>
+            </a:prstGeom>
+            <a:solidFill>
+              <a:srgbClr val="F7F1DF"/>
+            </a:solidFill>
+            <a:ln>
+              <a:noFill/>
+            </a:ln>
+          </p:spPr>
+          <p:txBody>
+            <a:bodyPr rtlCol="0" anchor="ctr"/>
+            <a:lstStyle/>
+            <a:p>
+              <a:pPr algn="ctr"/>
+            </a:p>
+          </p:txBody>
+        </p:sp>
+        <p:sp>
+          <p:nvSpPr>
+            <p:cNvPr id="61" name="TextBox 60"/>
+            <p:cNvSpPr txBox="1"/>
+            <p:nvPr/>
+          </p:nvSpPr>
+          <p:spPr>
+            <a:xfrm>
+              <a:off x="4800600" y="3986784"/>
+              <a:ext cx="1600200" cy="585216"/>
+            </a:xfrm>
+            <a:prstGeom prst="rect">
+              <a:avLst/>
+            </a:prstGeom>
+            <a:noFill/>
+          </p:spPr>
+          <p:txBody>
+            <a:bodyPr wrap="square" anchor="ctr" lIns="0" rIns="0" tIns="0" bIns="0">
+              <a:spAutoFit/>
+            </a:bodyPr>
+            <a:lstStyle/>
+            <a:p>
+              <a:pPr algn="ctr">
+                <a:spcAft>
+                  <a:spcPts val="0"/>
+                </a:spcAft>
+              </a:pPr>
+              <a:r>
+                <a:rPr sz="2400" b="1" i="0">
+                  <a:solidFill>
+                    <a:srgbClr val="242D57"/>
+                  </a:solidFill>
+                  <a:latin typeface="Oswald"/>
+                </a:rPr>
+                <a:t>USD 69,89</a:t>
+              </a:r>
+            </a:p>
+          </p:txBody>
+        </p:sp>
+        <p:sp>
+          <p:nvSpPr>
+            <p:cNvPr id="62" name="Rectangle 61"/>
+            <p:cNvSpPr/>
+            <p:nvPr/>
+          </p:nvSpPr>
+          <p:spPr>
+            <a:xfrm>
+              <a:off x="6492240" y="3986784"/>
+              <a:ext cx="1965960" cy="585216"/>
+            </a:xfrm>
+            <a:prstGeom prst="rect">
+              <a:avLst/>
+            </a:prstGeom>
+            <a:solidFill>
+              <a:srgbClr val="F7F1DF"/>
+            </a:solidFill>
+            <a:ln>
+              <a:noFill/>
+            </a:ln>
+          </p:spPr>
+          <p:txBody>
+            <a:bodyPr rtlCol="0" anchor="ctr"/>
+            <a:lstStyle/>
+            <a:p>
+              <a:pPr algn="ctr"/>
+            </a:p>
+          </p:txBody>
+        </p:sp>
+        <p:sp>
+          <p:nvSpPr>
+            <p:cNvPr id="63" name="TextBox 62"/>
+            <p:cNvSpPr txBox="1"/>
+            <p:nvPr/>
+          </p:nvSpPr>
+          <p:spPr>
+            <a:xfrm>
+              <a:off x="6583680" y="3986784"/>
+              <a:ext cx="1783080" cy="585216"/>
+            </a:xfrm>
+            <a:prstGeom prst="rect">
+              <a:avLst/>
+            </a:prstGeom>
+            <a:noFill/>
+          </p:spPr>
+          <p:txBody>
+            <a:bodyPr wrap="square" anchor="ctr" lIns="0" rIns="0" tIns="0" bIns="0">
+              <a:spAutoFit/>
+            </a:bodyPr>
+            <a:lstStyle/>
+            <a:p>
+              <a:pPr algn="ctr">
+                <a:spcAft>
+                  <a:spcPts val="0"/>
+                </a:spcAft>
+              </a:pPr>
+              <a:r>
+                <a:rPr sz="2400" b="1" i="0">
+                  <a:solidFill>
+                    <a:srgbClr val="7D6520"/>
+                  </a:solidFill>
+                  <a:latin typeface="Oswald"/>
+                </a:rPr>
+                <a:t>USD 66,90</a:t>
+              </a:r>
+            </a:p>
+          </p:txBody>
+        </p:sp>
+        <p:sp>
+          <p:nvSpPr>
+            <p:cNvPr id="64" name="Rectangle 63"/>
+            <p:cNvSpPr/>
+            <p:nvPr/>
+          </p:nvSpPr>
+          <p:spPr>
+            <a:xfrm>
+              <a:off x="685800" y="4561027"/>
+              <a:ext cx="7772400" cy="10972"/>
+            </a:xfrm>
+            <a:prstGeom prst="rect">
+              <a:avLst/>
+            </a:prstGeom>
+            <a:solidFill>
+              <a:srgbClr val="D5DBEA"/>
+            </a:solidFill>
+            <a:ln>
+              <a:noFill/>
+            </a:ln>
+          </p:spPr>
+          <p:txBody>
+            <a:bodyPr rtlCol="0" anchor="ctr"/>
+            <a:lstStyle/>
+            <a:p>
+              <a:pPr algn="ctr"/>
+            </a:p>
+          </p:txBody>
+        </p:sp>
+        <p:sp>
+          <p:nvSpPr>
+            <p:cNvPr id="65" name="Rectangle 64"/>
+            <p:cNvSpPr/>
+            <p:nvPr/>
+          </p:nvSpPr>
+          <p:spPr>
+            <a:xfrm>
+              <a:off x="685800" y="3986784"/>
+              <a:ext cx="7772400" cy="27432"/>
+            </a:xfrm>
+            <a:prstGeom prst="rect">
+              <a:avLst/>
+            </a:prstGeom>
+            <a:solidFill>
+              <a:srgbClr val="C4A857"/>
+            </a:solidFill>
+            <a:ln>
+              <a:noFill/>
+            </a:ln>
+          </p:spPr>
+          <p:txBody>
+            <a:bodyPr rtlCol="0" anchor="ctr"/>
+            <a:lstStyle/>
+            <a:p>
+              <a:pPr algn="ctr"/>
+            </a:p>
+          </p:txBody>
+        </p:sp>
+      </p:grpSp>
+      <p:sp>
+        <p:nvSpPr>
+          <p:cNvPr id="66" name="Rectangle 65"/>
+          <p:cNvSpPr/>
+          <p:nvPr/>
+        </p:nvSpPr>
+        <p:spPr>
+          <a:xfrm>
+            <a:off x="6492240" y="2011680"/>
+            <a:ext cx="1965960" cy="2560320"/>
+          </a:xfrm>
+          <a:prstGeom prst="rect">
+            <a:avLst/>
+          </a:prstGeom>
+          <a:noFill/>
+          <a:ln w="38100">
+            <a:solidFill>
+              <a:srgbClr val="C4A857"/>
+            </a:solidFill>
+          </a:ln>
+        </p:spPr>
+        <p:txBody>
+          <a:bodyPr rtlCol="0" anchor="ctr"/>
+          <a:lstStyle/>
+          <a:p>
+            <a:pPr algn="ctr"/>
+          </a:p>
+        </p:txBody>
+      </p:sp>
+      <p:grpSp>
+        <p:nvGrpSpPr>
+          <p:cNvPr id="67" name="Group 66"/>
+          <p:cNvGrpSpPr/>
+          <p:nvPr/>
+        </p:nvGrpSpPr>
+        <p:grpSpPr>
+          <a:xfrm>
+            <a:off x="685800" y="4773168"/>
+            <a:ext cx="7909560" cy="658368"/>
+            <a:chOff x="685800" y="4773168"/>
+            <a:chExt cx="7909560" cy="658368"/>
+          </a:xfrm>
+        </p:grpSpPr>
+        <p:sp>
+          <p:nvSpPr>
+            <p:cNvPr id="68" name="Rectangle 67"/>
+            <p:cNvSpPr/>
+            <p:nvPr/>
+          </p:nvSpPr>
+          <p:spPr>
+            <a:xfrm>
+              <a:off x="685800" y="4773168"/>
+              <a:ext cx="7909560" cy="658368"/>
             </a:xfrm>
             <a:prstGeom prst="rect">
               <a:avLst/>
@@ -11553,59 +11830,20 @@
         </p:sp>
         <p:sp>
           <p:nvSpPr>
-            <p:cNvPr id="60" name="TextBox 59"/>
-            <p:cNvSpPr txBox="1"/>
-            <p:nvPr/>
-          </p:nvSpPr>
-          <p:spPr>
-            <a:xfrm>
-              <a:off x="3246120" y="3904487"/>
-              <a:ext cx="2057400" cy="429768"/>
-            </a:xfrm>
-            <a:prstGeom prst="rect">
-              <a:avLst/>
-            </a:prstGeom>
-            <a:noFill/>
-          </p:spPr>
-          <p:txBody>
-            <a:bodyPr wrap="square" anchor="ctr" lIns="0" rIns="0" tIns="0" bIns="0">
-              <a:spAutoFit/>
-            </a:bodyPr>
-            <a:lstStyle/>
-            <a:p>
-              <a:pPr algn="ctr">
-                <a:spcAft>
-                  <a:spcPts val="0"/>
-                </a:spcAft>
-              </a:pPr>
-              <a:r>
-                <a:rPr sz="1900" b="1" i="0">
-                  <a:solidFill>
-                    <a:srgbClr val="242D57"/>
-                  </a:solidFill>
-                  <a:latin typeface="Oswald"/>
-                </a:rPr>
-                <a:t>USD 3,50</a:t>
-              </a:r>
-            </a:p>
-          </p:txBody>
-        </p:sp>
-        <p:sp>
-          <p:nvSpPr>
-            <p:cNvPr id="61" name="Rectangle 60"/>
+            <p:cNvPr id="69" name="Rectangle 68"/>
             <p:cNvSpPr/>
             <p:nvPr/>
           </p:nvSpPr>
           <p:spPr>
             <a:xfrm>
-              <a:off x="5394960" y="3904487"/>
-              <a:ext cx="1645920" cy="429768"/>
+              <a:off x="685800" y="4773168"/>
+              <a:ext cx="54864" cy="658368"/>
             </a:xfrm>
             <a:prstGeom prst="rect">
               <a:avLst/>
             </a:prstGeom>
             <a:solidFill>
-              <a:srgbClr val="EDF0F7"/>
+              <a:srgbClr val="C4A857"/>
             </a:solidFill>
             <a:ln>
               <a:noFill/>
@@ -11621,194 +11859,14 @@
         </p:sp>
         <p:sp>
           <p:nvSpPr>
-            <p:cNvPr id="62" name="TextBox 61"/>
+            <p:cNvPr id="70" name="TextBox 69"/>
             <p:cNvSpPr txBox="1"/>
             <p:nvPr/>
           </p:nvSpPr>
           <p:spPr>
             <a:xfrm>
-              <a:off x="5486400" y="3904487"/>
-              <a:ext cx="1463040" cy="429768"/>
-            </a:xfrm>
-            <a:prstGeom prst="rect">
-              <a:avLst/>
-            </a:prstGeom>
-            <a:noFill/>
-          </p:spPr>
-          <p:txBody>
-            <a:bodyPr wrap="square" anchor="ctr" lIns="0" rIns="0" tIns="0" bIns="0">
-              <a:spAutoFit/>
-            </a:bodyPr>
-            <a:lstStyle/>
-            <a:p>
-              <a:pPr algn="ctr">
-                <a:spcAft>
-                  <a:spcPts val="0"/>
-                </a:spcAft>
-              </a:pPr>
-              <a:r>
-                <a:rPr sz="1300" b="0" i="1">
-                  <a:solidFill>
-                    <a:srgbClr val="5B6585"/>
-                  </a:solidFill>
-                  <a:latin typeface="Open Sans"/>
-                </a:rPr>
-                <a:t>en integración</a:t>
-              </a:r>
-            </a:p>
-          </p:txBody>
-        </p:sp>
-        <p:sp>
-          <p:nvSpPr>
-            <p:cNvPr id="63" name="Rectangle 62"/>
-            <p:cNvSpPr/>
-            <p:nvPr/>
-          </p:nvSpPr>
-          <p:spPr>
-            <a:xfrm>
-              <a:off x="7040880" y="3904487"/>
-              <a:ext cx="1645920" cy="429768"/>
-            </a:xfrm>
-            <a:prstGeom prst="rect">
-              <a:avLst/>
-            </a:prstGeom>
-            <a:solidFill>
-              <a:srgbClr val="EDF0F7"/>
-            </a:solidFill>
-            <a:ln>
-              <a:noFill/>
-            </a:ln>
-          </p:spPr>
-          <p:txBody>
-            <a:bodyPr rtlCol="0" anchor="ctr"/>
-            <a:lstStyle/>
-            <a:p>
-              <a:pPr algn="ctr"/>
-            </a:p>
-          </p:txBody>
-        </p:sp>
-        <p:sp>
-          <p:nvSpPr>
-            <p:cNvPr id="64" name="TextBox 63"/>
-            <p:cNvSpPr txBox="1"/>
-            <p:nvPr/>
-          </p:nvSpPr>
-          <p:spPr>
-            <a:xfrm>
-              <a:off x="7132320" y="3904487"/>
-              <a:ext cx="1463040" cy="429768"/>
-            </a:xfrm>
-            <a:prstGeom prst="rect">
-              <a:avLst/>
-            </a:prstGeom>
-            <a:noFill/>
-          </p:spPr>
-          <p:txBody>
-            <a:bodyPr wrap="square" anchor="ctr" lIns="0" rIns="0" tIns="0" bIns="0">
-              <a:spAutoFit/>
-            </a:bodyPr>
-            <a:lstStyle/>
-            <a:p>
-              <a:pPr algn="ctr">
-                <a:spcAft>
-                  <a:spcPts val="0"/>
-                </a:spcAft>
-              </a:pPr>
-              <a:r>
-                <a:rPr sz="1300" b="0" i="1">
-                  <a:solidFill>
-                    <a:srgbClr val="5B6585"/>
-                  </a:solidFill>
-                  <a:latin typeface="Open Sans"/>
-                </a:rPr>
-                <a:t>en integración</a:t>
-              </a:r>
-            </a:p>
-          </p:txBody>
-        </p:sp>
-        <p:sp>
-          <p:nvSpPr>
-            <p:cNvPr id="65" name="Rectangle 64"/>
-            <p:cNvSpPr/>
-            <p:nvPr/>
-          </p:nvSpPr>
-          <p:spPr>
-            <a:xfrm>
-              <a:off x="685800" y="4323283"/>
-              <a:ext cx="8001000" cy="10972"/>
-            </a:xfrm>
-            <a:prstGeom prst="rect">
-              <a:avLst/>
-            </a:prstGeom>
-            <a:solidFill>
-              <a:srgbClr val="D5DBEA"/>
-            </a:solidFill>
-            <a:ln>
-              <a:noFill/>
-            </a:ln>
-          </p:spPr>
-          <p:txBody>
-            <a:bodyPr rtlCol="0" anchor="ctr"/>
-            <a:lstStyle/>
-            <a:p>
-              <a:pPr algn="ctr"/>
-            </a:p>
-          </p:txBody>
-        </p:sp>
-      </p:grpSp>
-      <p:grpSp>
-        <p:nvGrpSpPr>
-          <p:cNvPr id="66" name="Group 65"/>
-          <p:cNvGrpSpPr/>
-          <p:nvPr/>
-        </p:nvGrpSpPr>
-        <p:grpSpPr>
-          <a:xfrm>
-            <a:off x="685800" y="4334255"/>
-            <a:ext cx="8001000" cy="539496"/>
-            <a:chOff x="685800" y="4334255"/>
-            <a:chExt cx="8001000" cy="539496"/>
-          </a:xfrm>
-        </p:grpSpPr>
-        <p:sp>
-          <p:nvSpPr>
-            <p:cNvPr id="67" name="Rectangle 66"/>
-            <p:cNvSpPr/>
-            <p:nvPr/>
-          </p:nvSpPr>
-          <p:spPr>
-            <a:xfrm>
-              <a:off x="685800" y="4334255"/>
-              <a:ext cx="2468880" cy="539496"/>
-            </a:xfrm>
-            <a:prstGeom prst="rect">
-              <a:avLst/>
-            </a:prstGeom>
-            <a:solidFill>
-              <a:srgbClr val="F7F1DF"/>
-            </a:solidFill>
-            <a:ln>
-              <a:noFill/>
-            </a:ln>
-          </p:spPr>
-          <p:txBody>
-            <a:bodyPr rtlCol="0" anchor="ctr"/>
-            <a:lstStyle/>
-            <a:p>
-              <a:pPr algn="ctr"/>
-            </a:p>
-          </p:txBody>
-        </p:sp>
-        <p:sp>
-          <p:nvSpPr>
-            <p:cNvPr id="68" name="TextBox 67"/>
-            <p:cNvSpPr txBox="1"/>
-            <p:nvPr/>
-          </p:nvSpPr>
-          <p:spPr>
-            <a:xfrm>
-              <a:off x="868680" y="4334255"/>
-              <a:ext cx="2240280" cy="539496"/>
+              <a:off x="886968" y="4773168"/>
+              <a:ext cx="7589520" cy="658368"/>
             </a:xfrm>
             <a:prstGeom prst="rect">
               <a:avLst/>
@@ -11827,496 +11885,22 @@
                 </a:spcAft>
               </a:pPr>
               <a:r>
-                <a:rPr sz="1400" b="1" i="0">
+                <a:rPr sz="1250" b="1" i="0">
                   <a:solidFill>
                     <a:srgbClr val="242D57"/>
                   </a:solidFill>
                   <a:latin typeface="Open Sans"/>
                 </a:rPr>
-                <a:t>Costo total</a:t>
+                <a:t>Recomendación del motor: C. El operador contratado cubre el 100 % de los pedidos, con los 6 críticos a tiempo y respuesta de 4 h. </a:t>
               </a:r>
-            </a:p>
-          </p:txBody>
-        </p:sp>
-        <p:sp>
-          <p:nvSpPr>
-            <p:cNvPr id="69" name="Rectangle 68"/>
-            <p:cNvSpPr/>
-            <p:nvPr/>
-          </p:nvSpPr>
-          <p:spPr>
-            <a:xfrm>
-              <a:off x="3154680" y="4334255"/>
-              <a:ext cx="2240280" cy="539496"/>
-            </a:xfrm>
-            <a:prstGeom prst="rect">
-              <a:avLst/>
-            </a:prstGeom>
-            <a:solidFill>
-              <a:srgbClr val="F7F1DF"/>
-            </a:solidFill>
-            <a:ln>
-              <a:noFill/>
-            </a:ln>
-          </p:spPr>
-          <p:txBody>
-            <a:bodyPr rtlCol="0" anchor="ctr"/>
-            <a:lstStyle/>
-            <a:p>
-              <a:pPr algn="ctr"/>
-            </a:p>
-          </p:txBody>
-        </p:sp>
-        <p:sp>
-          <p:nvSpPr>
-            <p:cNvPr id="70" name="TextBox 69"/>
-            <p:cNvSpPr txBox="1"/>
-            <p:nvPr/>
-          </p:nvSpPr>
-          <p:spPr>
-            <a:xfrm>
-              <a:off x="3246120" y="4334255"/>
-              <a:ext cx="2057400" cy="539496"/>
-            </a:xfrm>
-            <a:prstGeom prst="rect">
-              <a:avLst/>
-            </a:prstGeom>
-            <a:noFill/>
-          </p:spPr>
-          <p:txBody>
-            <a:bodyPr wrap="square" anchor="ctr" lIns="0" rIns="0" tIns="0" bIns="0">
-              <a:spAutoFit/>
-            </a:bodyPr>
-            <a:lstStyle/>
-            <a:p>
-              <a:pPr algn="ctr">
-                <a:spcAft>
-                  <a:spcPts val="0"/>
-                </a:spcAft>
-              </a:pPr>
               <a:r>
-                <a:rPr sz="2500" b="1" i="0">
-                  <a:solidFill>
-                    <a:srgbClr val="242D57"/>
-                  </a:solidFill>
-                  <a:latin typeface="Oswald"/>
-                </a:rPr>
-                <a:t>USD 19,94</a:t>
-              </a:r>
-            </a:p>
-          </p:txBody>
-        </p:sp>
-        <p:sp>
-          <p:nvSpPr>
-            <p:cNvPr id="71" name="Rectangle 70"/>
-            <p:cNvSpPr/>
-            <p:nvPr/>
-          </p:nvSpPr>
-          <p:spPr>
-            <a:xfrm>
-              <a:off x="5394960" y="4334255"/>
-              <a:ext cx="1645920" cy="539496"/>
-            </a:xfrm>
-            <a:prstGeom prst="rect">
-              <a:avLst/>
-            </a:prstGeom>
-            <a:solidFill>
-              <a:srgbClr val="F7F1DF"/>
-            </a:solidFill>
-            <a:ln>
-              <a:noFill/>
-            </a:ln>
-          </p:spPr>
-          <p:txBody>
-            <a:bodyPr rtlCol="0" anchor="ctr"/>
-            <a:lstStyle/>
-            <a:p>
-              <a:pPr algn="ctr"/>
-            </a:p>
-          </p:txBody>
-        </p:sp>
-        <p:sp>
-          <p:nvSpPr>
-            <p:cNvPr id="72" name="TextBox 71"/>
-            <p:cNvSpPr txBox="1"/>
-            <p:nvPr/>
-          </p:nvSpPr>
-          <p:spPr>
-            <a:xfrm>
-              <a:off x="5486400" y="4334255"/>
-              <a:ext cx="1463040" cy="539496"/>
-            </a:xfrm>
-            <a:prstGeom prst="rect">
-              <a:avLst/>
-            </a:prstGeom>
-            <a:noFill/>
-          </p:spPr>
-          <p:txBody>
-            <a:bodyPr wrap="square" anchor="ctr" lIns="0" rIns="0" tIns="0" bIns="0">
-              <a:spAutoFit/>
-            </a:bodyPr>
-            <a:lstStyle/>
-            <a:p>
-              <a:pPr algn="ctr">
-                <a:spcAft>
-                  <a:spcPts val="0"/>
-                </a:spcAft>
-              </a:pPr>
-              <a:r>
-                <a:rPr sz="1300" b="0" i="1">
-                  <a:solidFill>
-                    <a:srgbClr val="5B6585"/>
-                  </a:solidFill>
-                  <a:latin typeface="Open Sans"/>
-                </a:rPr>
-                <a:t>en integración</a:t>
-              </a:r>
-            </a:p>
-          </p:txBody>
-        </p:sp>
-        <p:sp>
-          <p:nvSpPr>
-            <p:cNvPr id="73" name="Rectangle 72"/>
-            <p:cNvSpPr/>
-            <p:nvPr/>
-          </p:nvSpPr>
-          <p:spPr>
-            <a:xfrm>
-              <a:off x="7040880" y="4334255"/>
-              <a:ext cx="1645920" cy="539496"/>
-            </a:xfrm>
-            <a:prstGeom prst="rect">
-              <a:avLst/>
-            </a:prstGeom>
-            <a:solidFill>
-              <a:srgbClr val="F7F1DF"/>
-            </a:solidFill>
-            <a:ln>
-              <a:noFill/>
-            </a:ln>
-          </p:spPr>
-          <p:txBody>
-            <a:bodyPr rtlCol="0" anchor="ctr"/>
-            <a:lstStyle/>
-            <a:p>
-              <a:pPr algn="ctr"/>
-            </a:p>
-          </p:txBody>
-        </p:sp>
-        <p:sp>
-          <p:nvSpPr>
-            <p:cNvPr id="74" name="TextBox 73"/>
-            <p:cNvSpPr txBox="1"/>
-            <p:nvPr/>
-          </p:nvSpPr>
-          <p:spPr>
-            <a:xfrm>
-              <a:off x="7132320" y="4334255"/>
-              <a:ext cx="1463040" cy="539496"/>
-            </a:xfrm>
-            <a:prstGeom prst="rect">
-              <a:avLst/>
-            </a:prstGeom>
-            <a:noFill/>
-          </p:spPr>
-          <p:txBody>
-            <a:bodyPr wrap="square" anchor="ctr" lIns="0" rIns="0" tIns="0" bIns="0">
-              <a:spAutoFit/>
-            </a:bodyPr>
-            <a:lstStyle/>
-            <a:p>
-              <a:pPr algn="ctr">
-                <a:spcAft>
-                  <a:spcPts val="0"/>
-                </a:spcAft>
-              </a:pPr>
-              <a:r>
-                <a:rPr sz="1300" b="0" i="1">
-                  <a:solidFill>
-                    <a:srgbClr val="5B6585"/>
-                  </a:solidFill>
-                  <a:latin typeface="Open Sans"/>
-                </a:rPr>
-                <a:t>en integración</a:t>
-              </a:r>
-            </a:p>
-          </p:txBody>
-        </p:sp>
-        <p:sp>
-          <p:nvSpPr>
-            <p:cNvPr id="75" name="Rectangle 74"/>
-            <p:cNvSpPr/>
-            <p:nvPr/>
-          </p:nvSpPr>
-          <p:spPr>
-            <a:xfrm>
-              <a:off x="685800" y="4862779"/>
-              <a:ext cx="8001000" cy="10972"/>
-            </a:xfrm>
-            <a:prstGeom prst="rect">
-              <a:avLst/>
-            </a:prstGeom>
-            <a:solidFill>
-              <a:srgbClr val="D5DBEA"/>
-            </a:solidFill>
-            <a:ln>
-              <a:noFill/>
-            </a:ln>
-          </p:spPr>
-          <p:txBody>
-            <a:bodyPr rtlCol="0" anchor="ctr"/>
-            <a:lstStyle/>
-            <a:p>
-              <a:pPr algn="ctr"/>
-            </a:p>
-          </p:txBody>
-        </p:sp>
-        <p:sp>
-          <p:nvSpPr>
-            <p:cNvPr id="76" name="Rectangle 75"/>
-            <p:cNvSpPr/>
-            <p:nvPr/>
-          </p:nvSpPr>
-          <p:spPr>
-            <a:xfrm>
-              <a:off x="685800" y="4334255"/>
-              <a:ext cx="8001000" cy="27432"/>
-            </a:xfrm>
-            <a:prstGeom prst="rect">
-              <a:avLst/>
-            </a:prstGeom>
-            <a:solidFill>
-              <a:srgbClr val="C4A857"/>
-            </a:solidFill>
-            <a:ln>
-              <a:noFill/>
-            </a:ln>
-          </p:spPr>
-          <p:txBody>
-            <a:bodyPr rtlCol="0" anchor="ctr"/>
-            <a:lstStyle/>
-            <a:p>
-              <a:pPr algn="ctr"/>
-            </a:p>
-          </p:txBody>
-        </p:sp>
-      </p:grpSp>
-      <p:sp>
-        <p:nvSpPr>
-          <p:cNvPr id="77" name="TextBox 76"/>
-          <p:cNvSpPr txBox="1"/>
-          <p:nvPr/>
-        </p:nvSpPr>
-        <p:spPr>
-          <a:xfrm>
-            <a:off x="685800" y="5001767"/>
-            <a:ext cx="7909560" cy="548640"/>
-          </a:xfrm>
-          <a:prstGeom prst="rect">
-            <a:avLst/>
-          </a:prstGeom>
-          <a:noFill/>
-        </p:spPr>
-        <p:txBody>
-          <a:bodyPr wrap="square" anchor="t" lIns="0" rIns="0" tIns="0" bIns="0">
-            <a:spAutoFit/>
-          </a:bodyPr>
-          <a:lstStyle/>
-          <a:p>
-            <a:pPr algn="l">
-              <a:spcAft>
-                <a:spcPts val="0"/>
-              </a:spcAft>
-            </a:pPr>
-            <a:r>
-              <a:rPr sz="1400" b="0" i="1">
-                <a:solidFill>
-                  <a:srgbClr val="242D57"/>
-                </a:solidFill>
-                <a:latin typeface="Open Sans"/>
-              </a:rPr>
-              <a:t>«El costo de una ruta no es solo kilómetros: sumamos combustible según carga, personas que descargan y merma esperada».</a:t>
-            </a:r>
-          </a:p>
-        </p:txBody>
-      </p:sp>
-      <p:grpSp>
-        <p:nvGrpSpPr>
-          <p:cNvPr id="78" name="Group 77"/>
-          <p:cNvGrpSpPr/>
-          <p:nvPr/>
-        </p:nvGrpSpPr>
-        <p:grpSpPr>
-          <a:xfrm>
-            <a:off x="685800" y="5559552"/>
-            <a:ext cx="7909560" cy="548640"/>
-            <a:chOff x="685800" y="5559552"/>
-            <a:chExt cx="7909560" cy="548640"/>
-          </a:xfrm>
-        </p:grpSpPr>
-        <p:sp>
-          <p:nvSpPr>
-            <p:cNvPr id="79" name="Rectangle 78"/>
-            <p:cNvSpPr/>
-            <p:nvPr/>
-          </p:nvSpPr>
-          <p:spPr>
-            <a:xfrm>
-              <a:off x="685800" y="5559552"/>
-              <a:ext cx="5074920" cy="548640"/>
-            </a:xfrm>
-            <a:prstGeom prst="rect">
-              <a:avLst/>
-            </a:prstGeom>
-            <a:solidFill>
-              <a:srgbClr val="EDF0F7"/>
-            </a:solidFill>
-            <a:ln>
-              <a:noFill/>
-            </a:ln>
-          </p:spPr>
-          <p:txBody>
-            <a:bodyPr rtlCol="0" anchor="ctr"/>
-            <a:lstStyle/>
-            <a:p>
-              <a:pPr algn="ctr"/>
-            </a:p>
-          </p:txBody>
-        </p:sp>
-        <p:sp>
-          <p:nvSpPr>
-            <p:cNvPr id="80" name="Rectangle 79"/>
-            <p:cNvSpPr/>
-            <p:nvPr/>
-          </p:nvSpPr>
-          <p:spPr>
-            <a:xfrm>
-              <a:off x="685800" y="5559552"/>
-              <a:ext cx="54864" cy="548640"/>
-            </a:xfrm>
-            <a:prstGeom prst="rect">
-              <a:avLst/>
-            </a:prstGeom>
-            <a:solidFill>
-              <a:srgbClr val="C4A857"/>
-            </a:solidFill>
-            <a:ln>
-              <a:noFill/>
-            </a:ln>
-          </p:spPr>
-          <p:txBody>
-            <a:bodyPr rtlCol="0" anchor="ctr"/>
-            <a:lstStyle/>
-            <a:p>
-              <a:pPr algn="ctr"/>
-            </a:p>
-          </p:txBody>
-        </p:sp>
-        <p:sp>
-          <p:nvSpPr>
-            <p:cNvPr id="81" name="TextBox 80"/>
-            <p:cNvSpPr txBox="1"/>
-            <p:nvPr/>
-          </p:nvSpPr>
-          <p:spPr>
-            <a:xfrm>
-              <a:off x="886968" y="5559552"/>
-              <a:ext cx="4754880" cy="548640"/>
-            </a:xfrm>
-            <a:prstGeom prst="rect">
-              <a:avLst/>
-            </a:prstGeom>
-            <a:noFill/>
-          </p:spPr>
-          <p:txBody>
-            <a:bodyPr wrap="square" anchor="ctr" lIns="0" rIns="0" tIns="0" bIns="0">
-              <a:spAutoFit/>
-            </a:bodyPr>
-            <a:lstStyle/>
-            <a:p>
-              <a:pPr algn="l">
-                <a:spcAft>
-                  <a:spcPts val="0"/>
-                </a:spcAft>
-              </a:pPr>
-              <a:r>
-                <a:rPr sz="1200" b="1" i="0">
+                <a:rPr sz="1250" b="0" i="0">
                   <a:solidFill>
                     <a:srgbClr val="242D57"/>
                   </a:solidFill>
                   <a:latin typeface="Open Sans"/>
                 </a:rPr>
-                <a:t>La comparación con operador contratado y la recomendación calculada se integran en #241.</a:t>
-              </a:r>
-            </a:p>
-          </p:txBody>
-        </p:sp>
-        <p:sp>
-          <p:nvSpPr>
-            <p:cNvPr id="82" name="Rectangle 81"/>
-            <p:cNvSpPr/>
-            <p:nvPr/>
-          </p:nvSpPr>
-          <p:spPr>
-            <a:xfrm>
-              <a:off x="5897880" y="5559552"/>
-              <a:ext cx="2697480" cy="548640"/>
-            </a:xfrm>
-            <a:prstGeom prst="rect">
-              <a:avLst/>
-            </a:prstGeom>
-            <a:solidFill>
-              <a:srgbClr val="FFFFFF"/>
-            </a:solidFill>
-            <a:ln w="12700">
-              <a:solidFill>
-                <a:srgbClr val="5B6585"/>
-              </a:solidFill>
-            </a:ln>
-          </p:spPr>
-          <p:txBody>
-            <a:bodyPr rtlCol="0" anchor="ctr"/>
-            <a:lstStyle/>
-            <a:p>
-              <a:pPr algn="ctr"/>
-            </a:p>
-          </p:txBody>
-        </p:sp>
-        <p:sp>
-          <p:nvSpPr>
-            <p:cNvPr id="83" name="TextBox 82"/>
-            <p:cNvSpPr txBox="1"/>
-            <p:nvPr/>
-          </p:nvSpPr>
-          <p:spPr>
-            <a:xfrm>
-              <a:off x="5989320" y="5559552"/>
-              <a:ext cx="2514600" cy="548640"/>
-            </a:xfrm>
-            <a:prstGeom prst="rect">
-              <a:avLst/>
-            </a:prstGeom>
-            <a:noFill/>
-          </p:spPr>
-          <p:txBody>
-            <a:bodyPr wrap="square" anchor="ctr" lIns="0" rIns="0" tIns="0" bIns="0">
-              <a:spAutoFit/>
-            </a:bodyPr>
-            <a:lstStyle/>
-            <a:p>
-              <a:pPr algn="ctr">
-                <a:spcAft>
-                  <a:spcPts val="0"/>
-                </a:spcAft>
-              </a:pPr>
-              <a:r>
-                <a:rPr sz="1200" b="1" i="0">
-                  <a:solidFill>
-                    <a:srgbClr val="5B6585"/>
-                  </a:solidFill>
-                  <a:latin typeface="Open Sans"/>
-                </a:rPr>
-                <a:t>[CAPTURA PENDIENTE: pantalla A/B/C]</a:t>
+                <a:t>La más barata no siempre es la mejor: A deja un crítico fuera de ventana. El planificador decide.</a:t>
               </a:r>
             </a:p>
           </p:txBody>
@@ -12324,7 +11908,7 @@
       </p:grpSp>
       <p:sp>
         <p:nvSpPr>
-          <p:cNvPr id="84" name="Rounded Rectangular Callout 83"/>
+          <p:cNvPr id="71" name="Rounded Rectangular Callout 70"/>
           <p:cNvSpPr/>
           <p:nvPr/>
         </p:nvSpPr>
@@ -12559,7 +12143,7 @@
                                           </p:stCondLst>
                                         </p:cTn>
                                         <p:tgtEl>
-                                          <p:spTgt spid="25"/>
+                                          <p:spTgt spid="24"/>
                                         </p:tgtEl>
                                         <p:attrNameLst>
                                           <p:attrName>style.visibility</p:attrName>
@@ -12573,7 +12157,7 @@
                                       <p:cBhvr>
                                         <p:cTn id="17" dur="500" fill="hold"/>
                                         <p:tgtEl>
-                                          <p:spTgt spid="25"/>
+                                          <p:spTgt spid="24"/>
                                         </p:tgtEl>
                                         <p:attrNameLst>
                                           <p:attrName>ppt_w</p:attrName>
@@ -12596,7 +12180,7 @@
                                       <p:cBhvr>
                                         <p:cTn id="18" dur="500" fill="hold"/>
                                         <p:tgtEl>
-                                          <p:spTgt spid="25"/>
+                                          <p:spTgt spid="24"/>
                                         </p:tgtEl>
                                         <p:attrNameLst>
                                           <p:attrName>ppt_h</p:attrName>
@@ -12619,7 +12203,7 @@
                                       <p:cBhvr>
                                         <p:cTn id="19" dur="500"/>
                                         <p:tgtEl>
-                                          <p:spTgt spid="25"/>
+                                          <p:spTgt spid="24"/>
                                         </p:tgtEl>
                                       </p:cBhvr>
                                     </p:animEffect>
@@ -12658,7 +12242,7 @@
                                           </p:stCondLst>
                                         </p:cTn>
                                         <p:tgtEl>
-                                          <p:spTgt spid="26"/>
+                                          <p:spTgt spid="25"/>
                                         </p:tgtEl>
                                         <p:attrNameLst>
                                           <p:attrName>style.visibility</p:attrName>
@@ -12672,7 +12256,7 @@
                                       <p:cBhvr>
                                         <p:cTn id="24" dur="300"/>
                                         <p:tgtEl>
-                                          <p:spTgt spid="26"/>
+                                          <p:spTgt spid="25"/>
                                         </p:tgtEl>
                                       </p:cBhvr>
                                     </p:animEffect>
@@ -12702,7 +12286,7 @@
                                           </p:stCondLst>
                                         </p:cTn>
                                         <p:tgtEl>
-                                          <p:spTgt spid="36"/>
+                                          <p:spTgt spid="35"/>
                                         </p:tgtEl>
                                         <p:attrNameLst>
                                           <p:attrName>style.visibility</p:attrName>
@@ -12716,7 +12300,7 @@
                                       <p:cBhvr>
                                         <p:cTn id="28" dur="300"/>
                                         <p:tgtEl>
-                                          <p:spTgt spid="36"/>
+                                          <p:spTgt spid="35"/>
                                         </p:tgtEl>
                                       </p:cBhvr>
                                     </p:animEffect>
@@ -12746,7 +12330,7 @@
                                           </p:stCondLst>
                                         </p:cTn>
                                         <p:tgtEl>
-                                          <p:spTgt spid="46"/>
+                                          <p:spTgt spid="45"/>
                                         </p:tgtEl>
                                         <p:attrNameLst>
                                           <p:attrName>style.visibility</p:attrName>
@@ -12760,51 +12344,7 @@
                                       <p:cBhvr>
                                         <p:cTn id="32" dur="300"/>
                                         <p:tgtEl>
-                                          <p:spTgt spid="46"/>
-                                        </p:tgtEl>
-                                      </p:cBhvr>
-                                    </p:animEffect>
-                                  </p:childTnLst>
-                                </p:cTn>
-                              </p:par>
-                            </p:childTnLst>
-                          </p:cTn>
-                        </p:par>
-                        <p:par>
-                          <p:cTn id="34" fill="hold">
-                            <p:stCondLst>
-                              <p:cond delay="900"/>
-                            </p:stCondLst>
-                            <p:childTnLst>
-                              <p:par>
-                                <p:cTn id="37" presetID="22" presetClass="entr" presetSubtype="8" fill="hold" grpId="0" nodeType="afterEffect">
-                                  <p:stCondLst>
-                                    <p:cond delay="0"/>
-                                  </p:stCondLst>
-                                  <p:childTnLst>
-                                    <p:set>
-                                      <p:cBhvr>
-                                        <p:cTn id="35" dur="1" fill="hold">
-                                          <p:stCondLst>
-                                            <p:cond delay="0"/>
-                                          </p:stCondLst>
-                                        </p:cTn>
-                                        <p:tgtEl>
-                                          <p:spTgt spid="56"/>
-                                        </p:tgtEl>
-                                        <p:attrNameLst>
-                                          <p:attrName>style.visibility</p:attrName>
-                                        </p:attrNameLst>
-                                      </p:cBhvr>
-                                      <p:to>
-                                        <p:strVal val="visible"/>
-                                      </p:to>
-                                    </p:set>
-                                    <p:animEffect transition="in" filter="wipe(left)">
-                                      <p:cBhvr>
-                                        <p:cTn id="36" dur="300"/>
-                                        <p:tgtEl>
-                                          <p:spTgt spid="56"/>
+                                          <p:spTgt spid="45"/>
                                         </p:tgtEl>
                                       </p:cBhvr>
                                     </p:animEffect>
@@ -12818,19 +12358,63 @@
                     </p:cTn>
                   </p:par>
                   <p:par>
-                    <p:cTn id="38" fill="hold">
+                    <p:cTn id="34" fill="hold">
                       <p:stCondLst>
                         <p:cond delay="indefinite"/>
                       </p:stCondLst>
                       <p:childTnLst>
                         <p:par>
-                          <p:cTn id="39" fill="hold">
+                          <p:cTn id="35" fill="hold">
                             <p:stCondLst>
                               <p:cond delay="0"/>
                             </p:stCondLst>
                             <p:childTnLst>
                               <p:par>
-                                <p:cTn id="42" presetID="10" presetClass="entr" presetSubtype="0" fill="hold" grpId="0" nodeType="clickEffect">
+                                <p:cTn id="38" presetID="10" presetClass="entr" presetSubtype="0" fill="hold" grpId="0" nodeType="clickEffect">
+                                  <p:stCondLst>
+                                    <p:cond delay="0"/>
+                                  </p:stCondLst>
+                                  <p:childTnLst>
+                                    <p:set>
+                                      <p:cBhvr>
+                                        <p:cTn id="36" dur="1" fill="hold">
+                                          <p:stCondLst>
+                                            <p:cond delay="0"/>
+                                          </p:stCondLst>
+                                        </p:cTn>
+                                        <p:tgtEl>
+                                          <p:spTgt spid="55"/>
+                                        </p:tgtEl>
+                                        <p:attrNameLst>
+                                          <p:attrName>style.visibility</p:attrName>
+                                        </p:attrNameLst>
+                                      </p:cBhvr>
+                                      <p:to>
+                                        <p:strVal val="visible"/>
+                                      </p:to>
+                                    </p:set>
+                                    <p:animEffect transition="in" filter="fade">
+                                      <p:cBhvr>
+                                        <p:cTn id="37" dur="450"/>
+                                        <p:tgtEl>
+                                          <p:spTgt spid="55"/>
+                                        </p:tgtEl>
+                                      </p:cBhvr>
+                                    </p:animEffect>
+                                  </p:childTnLst>
+                                </p:cTn>
+                              </p:par>
+                            </p:childTnLst>
+                          </p:cTn>
+                        </p:par>
+                        <p:par>
+                          <p:cTn id="39" fill="hold">
+                            <p:stCondLst>
+                              <p:cond delay="450"/>
+                            </p:stCondLst>
+                            <p:childTnLst>
+                              <p:par>
+                                <p:cTn id="42" presetID="10" presetClass="entr" presetSubtype="0" fill="hold" grpId="0" nodeType="afterEffect">
                                   <p:stCondLst>
                                     <p:cond delay="0"/>
                                   </p:stCondLst>
@@ -12855,7 +12439,7 @@
                                     </p:set>
                                     <p:animEffect transition="in" filter="fade">
                                       <p:cBhvr>
-                                        <p:cTn id="41" dur="450"/>
+                                        <p:cTn id="41" dur="400"/>
                                         <p:tgtEl>
                                           <p:spTgt spid="66"/>
                                         </p:tgtEl>
@@ -12870,7 +12454,7 @@
                         <p:par>
                           <p:cTn id="43" fill="hold">
                             <p:stCondLst>
-                              <p:cond delay="450"/>
+                              <p:cond delay="850"/>
                             </p:stCondLst>
                             <p:childTnLst>
                               <p:par>
@@ -12887,7 +12471,7 @@
                                           </p:stCondLst>
                                         </p:cTn>
                                         <p:tgtEl>
-                                          <p:spTgt spid="77"/>
+                                          <p:spTgt spid="67"/>
                                         </p:tgtEl>
                                         <p:attrNameLst>
                                           <p:attrName>style.visibility</p:attrName>
@@ -12901,42 +12485,7 @@
                                       <p:cBhvr>
                                         <p:cTn id="45" dur="400"/>
                                         <p:tgtEl>
-                                          <p:spTgt spid="77"/>
-                                        </p:tgtEl>
-                                      </p:cBhvr>
-                                    </p:animEffect>
-                                  </p:childTnLst>
-                                </p:cTn>
-                              </p:par>
-                              <p:par>
-                                <p:cTn id="49" presetID="10" presetClass="entr" presetSubtype="0" fill="hold" grpId="0" nodeType="withEffect">
-                                  <p:stCondLst>
-                                    <p:cond delay="0"/>
-                                  </p:stCondLst>
-                                  <p:childTnLst>
-                                    <p:set>
-                                      <p:cBhvr>
-                                        <p:cTn id="47" dur="1" fill="hold">
-                                          <p:stCondLst>
-                                            <p:cond delay="0"/>
-                                          </p:stCondLst>
-                                        </p:cTn>
-                                        <p:tgtEl>
-                                          <p:spTgt spid="78"/>
-                                        </p:tgtEl>
-                                        <p:attrNameLst>
-                                          <p:attrName>style.visibility</p:attrName>
-                                        </p:attrNameLst>
-                                      </p:cBhvr>
-                                      <p:to>
-                                        <p:strVal val="visible"/>
-                                      </p:to>
-                                    </p:set>
-                                    <p:animEffect transition="in" filter="fade">
-                                      <p:cBhvr>
-                                        <p:cTn id="48" dur="400"/>
-                                        <p:tgtEl>
-                                          <p:spTgt spid="78"/>
+                                          <p:spTgt spid="67"/>
                                         </p:tgtEl>
                                       </p:cBhvr>
                                     </p:animEffect>
@@ -12950,32 +12499,32 @@
                     </p:cTn>
                   </p:par>
                   <p:par>
-                    <p:cTn id="50" fill="hold">
+                    <p:cTn id="47" fill="hold">
                       <p:stCondLst>
                         <p:cond delay="indefinite"/>
                       </p:stCondLst>
                       <p:childTnLst>
                         <p:par>
-                          <p:cTn id="51" fill="hold">
+                          <p:cTn id="48" fill="hold">
                             <p:stCondLst>
                               <p:cond delay="0"/>
                             </p:stCondLst>
                             <p:childTnLst>
                               <p:par>
-                                <p:cTn id="54" presetID="10" presetClass="entr" presetSubtype="0" fill="hold" grpId="0" nodeType="clickEffect">
+                                <p:cTn id="51" presetID="10" presetClass="entr" presetSubtype="0" fill="hold" grpId="0" nodeType="clickEffect">
                                   <p:stCondLst>
                                     <p:cond delay="0"/>
                                   </p:stCondLst>
                                   <p:childTnLst>
                                     <p:set>
                                       <p:cBhvr>
-                                        <p:cTn id="52" dur="1" fill="hold">
+                                        <p:cTn id="49" dur="1" fill="hold">
                                           <p:stCondLst>
                                             <p:cond delay="0"/>
                                           </p:stCondLst>
                                         </p:cTn>
                                         <p:tgtEl>
-                                          <p:spTgt spid="84"/>
+                                          <p:spTgt spid="71"/>
                                         </p:tgtEl>
                                         <p:attrNameLst>
                                           <p:attrName>style.visibility</p:attrName>
@@ -12987,9 +12536,9 @@
                                     </p:set>
                                     <p:animEffect transition="in" filter="fade">
                                       <p:cBhvr>
-                                        <p:cTn id="53" dur="400"/>
+                                        <p:cTn id="50" dur="400"/>
                                         <p:tgtEl>
-                                          <p:spTgt spid="84"/>
+                                          <p:spTgt spid="71"/>
                                         </p:tgtEl>
                                       </p:cBhvr>
                                     </p:animEffect>
@@ -13024,8 +12573,8 @@
       </p:par>
     </p:tnLst>
     <p:bldLst>
-      <p:bldP spid="77" grpId="0" animBg="1"/>
-      <p:bldP spid="84" grpId="0" animBg="1"/>
+      <p:bldP spid="66" grpId="0" animBg="1"/>
+      <p:bldP spid="71" grpId="0" animBg="1"/>
     </p:bldLst>
   </p:timing>
 </p:sld>

</xml_diff>

<commit_message>
docs(pitch): porcentajes en la lámina 5 (críticos a tiempo y costo frente a A)
Críticos a tiempo 83 % / 100 % / 100 %; costo frente a A: B +20,7 %, C +15,6 %;
C cuesta 4,3 % menos que B. Derivados de los totales del ensayo #285. Guion,
video de respaldo y registro de clics alineados.

Refs #200

Co-Authored-By: Claude Opus 5.5 <noreply@anthropic.com>
Claude-Session: https://claude.ai/code/session_01NsJaDshCcYpgTrfc71p237
</commit_message>
<xml_diff>
--- a/docs/specs/006-validacion-pitch-entrega/materiales/pitch-v3.pptx
+++ b/docs/specs/006-validacion-pitch-entrega/materiales/pitch-v3.pptx
@@ -10540,7 +10540,7 @@
                   </a:solidFill>
                   <a:latin typeface="Open Sans"/>
                 </a:rPr>
-                <a:t>Flota</a:t>
+                <a:t>Críticos a tiempo</a:t>
               </a:r>
             </a:p>
           </p:txBody>
@@ -10608,7 +10608,7 @@
                   </a:solidFill>
                   <a:latin typeface="Oswald"/>
                 </a:rPr>
-                <a:t>Propia</a:t>
+                <a:t>83 % (5 de 6)</a:t>
               </a:r>
             </a:p>
           </p:txBody>
@@ -10676,7 +10676,7 @@
                   </a:solidFill>
                   <a:latin typeface="Oswald"/>
                 </a:rPr>
-                <a:t>Propia</a:t>
+                <a:t>100 % (6 de 6)</a:t>
               </a:r>
             </a:p>
           </p:txBody>
@@ -10744,7 +10744,7 @@
                   </a:solidFill>
                   <a:latin typeface="Oswald"/>
                 </a:rPr>
-                <a:t>Contratada</a:t>
+                <a:t>100 % (6 de 6)</a:t>
               </a:r>
             </a:p>
           </p:txBody>
@@ -10856,7 +10856,7 @@
                   </a:solidFill>
                   <a:latin typeface="Open Sans"/>
                 </a:rPr>
-                <a:t>Críticos a tiempo</a:t>
+                <a:t>Costo frente a A</a:t>
               </a:r>
             </a:p>
           </p:txBody>
@@ -10924,7 +10924,7 @@
                   </a:solidFill>
                   <a:latin typeface="Oswald"/>
                 </a:rPr>
-                <a:t>5 de 6</a:t>
+                <a:t>base</a:t>
               </a:r>
             </a:p>
           </p:txBody>
@@ -10992,7 +10992,7 @@
                   </a:solidFill>
                   <a:latin typeface="Oswald"/>
                 </a:rPr>
-                <a:t>6 de 6</a:t>
+                <a:t>+20,7 %</a:t>
               </a:r>
             </a:p>
           </p:txBody>
@@ -11060,7 +11060,7 @@
                   </a:solidFill>
                   <a:latin typeface="Oswald"/>
                 </a:rPr>
-                <a:t>6 de 6</a:t>
+                <a:t>+15,6 %</a:t>
               </a:r>
             </a:p>
           </p:txBody>
@@ -11891,7 +11891,7 @@
                   </a:solidFill>
                   <a:latin typeface="Open Sans"/>
                 </a:rPr>
-                <a:t>Recomendación del motor: C. El operador contratado cubre el 100 % de los pedidos, con los 6 críticos a tiempo y respuesta de 4 h. </a:t>
+                <a:t>Recomendación del motor: C. Por un 15,6 % más que A, cumple el 100 % de los críticos; frente a B, que también cumple, cuesta un 4,3 % menos. </a:t>
               </a:r>
               <a:r>
                 <a:rPr sz="1250" b="0" i="0">
@@ -11900,7 +11900,7 @@
                   </a:solidFill>
                   <a:latin typeface="Open Sans"/>
                 </a:rPr>
-                <a:t>La más barata no siempre es la mejor: A deja un crítico fuera de ventana. El planificador decide.</a:t>
+                <a:t>La más barata no siempre es la mejor. El planificador decide.</a:t>
               </a:r>
             </a:p>
           </p:txBody>

</xml_diff>